<commit_message>
Deck slide 1: budget = BU revision; slide 2 KPI targets stay approved
Co-Authored-By: Claude Opus 5.5 <noreply@anthropic.com>
Claude-Session: https://claude.ai/code/session_0142u1JgEJ5Z4iqbgjpLWfcB
</commit_message>
<xml_diff>
--- a/OMNI_weekly_AdTech_Sept.pptx
+++ b/OMNI_weekly_AdTech_Sept.pptx
@@ -15350,7 +15350,7 @@
           <a:p>
             <a:r>
               <a:rPr lang="ru-RU" dirty="0"/>
-              <a:t>* - Прогноз 2026 = факт 9 мес. + прогноз 3 мес.; сентябрь — предв. факт (выручка по Rev); бюджет — утверждённый BU; «+» к бюджету — улучшение (по расходам — экономия)</a:t>
+              <a:t>* - Прогноз 2026 = факт 9 мес. + прогноз 3 мес.; сентябрь — предв. факт (выручка по Rev); бюджет — ревизия BU (выручка — утверждённый BU); «+» к бюджету — улучшение (по расходам — экономия)</a:t>
             </a:r>
             <a:br>
               <a:rPr lang="ru-RU" dirty="0"/>
@@ -19744,7 +19744,7 @@
                           </a:solidFill>
                           <a:latin typeface="Arial"/>
                         </a:rPr>
-                        <a:t>-222</a:t>
+                        <a:t>-577</a:t>
                       </a:r>
                     </a:p>
                   </a:txBody>
@@ -19790,7 +19790,7 @@
                           </a:solidFill>
                           <a:latin typeface="Arial"/>
                         </a:rPr>
-                        <a:t>+148</a:t>
+                        <a:t>+503</a:t>
                       </a:r>
                     </a:p>
                   </a:txBody>
@@ -19836,7 +19836,7 @@
                           </a:solidFill>
                           <a:latin typeface="Arial"/>
                         </a:rPr>
-                        <a:t>+66,4%</a:t>
+                        <a:t>+87,1%</a:t>
                       </a:r>
                     </a:p>
                   </a:txBody>
@@ -19970,7 +19970,7 @@
                           </a:solidFill>
                           <a:latin typeface="Arial"/>
                         </a:rPr>
-                        <a:t>Рекласс ФОТ в CAPEX +180 млн (разово)</a:t>
+                        <a:t>Маркетинг −106 (бюджет −468), ФОТ в CAPEX +180</a:t>
                       </a:r>
                     </a:p>
                   </a:txBody>
@@ -20105,7 +20105,7 @@
                           </a:solidFill>
                           <a:latin typeface="Arial"/>
                         </a:rPr>
-                        <a:t>-2 397</a:t>
+                        <a:t>-2 789</a:t>
                       </a:r>
                     </a:p>
                   </a:txBody>
@@ -20151,7 +20151,7 @@
                           </a:solidFill>
                           <a:latin typeface="Arial"/>
                         </a:rPr>
-                        <a:t>+1,4%</a:t>
+                        <a:t>+15,2%</a:t>
                       </a:r>
                     </a:p>
                   </a:txBody>
@@ -20405,7 +20405,7 @@
                           </a:solidFill>
                           <a:latin typeface="Arial"/>
                         </a:rPr>
-                        <a:t>438</a:t>
+                        <a:t>83</a:t>
                       </a:r>
                     </a:p>
                   </a:txBody>
@@ -20453,7 +20453,7 @@
                           </a:solidFill>
                           <a:latin typeface="Arial"/>
                         </a:rPr>
-                        <a:t>+499</a:t>
+                        <a:t>+854</a:t>
                       </a:r>
                     </a:p>
                   </a:txBody>
@@ -20501,7 +20501,7 @@
                           </a:solidFill>
                           <a:latin typeface="Arial"/>
                         </a:rPr>
-                        <a:t>+113,8%</a:t>
+                        <a:t>+1028,6%</a:t>
                       </a:r>
                     </a:p>
                   </a:txBody>
@@ -20778,7 +20778,7 @@
                           </a:solidFill>
                           <a:latin typeface="Arial"/>
                         </a:rPr>
-                        <a:t>3 450</a:t>
+                        <a:t>3 058</a:t>
                       </a:r>
                     </a:p>
                   </a:txBody>
@@ -20826,7 +20826,7 @@
                           </a:solidFill>
                           <a:latin typeface="Arial"/>
                         </a:rPr>
-                        <a:t>+144,5%</a:t>
+                        <a:t>+175,9%</a:t>
                       </a:r>
                     </a:p>
                   </a:txBody>
@@ -21080,7 +21080,7 @@
                           </a:solidFill>
                           <a:latin typeface="Arial"/>
                         </a:rPr>
-                        <a:t>149</a:t>
+                        <a:t>-206</a:t>
                       </a:r>
                     </a:p>
                   </a:txBody>
@@ -21126,7 +21126,7 @@
                           </a:solidFill>
                           <a:latin typeface="Arial"/>
                         </a:rPr>
-                        <a:t>+542</a:t>
+                        <a:t>+897</a:t>
                       </a:r>
                     </a:p>
                   </a:txBody>
@@ -21172,7 +21172,7 @@
                           </a:solidFill>
                           <a:latin typeface="Arial"/>
                         </a:rPr>
-                        <a:t>+365,0%</a:t>
+                        <a:t>+434,8%</a:t>
                       </a:r>
                     </a:p>
                   </a:txBody>
@@ -21433,7 +21433,7 @@
                           </a:solidFill>
                           <a:latin typeface="Arial"/>
                         </a:rPr>
-                        <a:t>1 117</a:t>
+                        <a:t>725</a:t>
                       </a:r>
                     </a:p>
                   </a:txBody>
@@ -21479,7 +21479,7 @@
                           </a:solidFill>
                           <a:latin typeface="Arial"/>
                         </a:rPr>
-                        <a:t>+201,2%</a:t>
+                        <a:t>+363,8%</a:t>
                       </a:r>
                     </a:p>
                   </a:txBody>
@@ -22406,7 +22406,7 @@
                           </a:solidFill>
                           <a:latin typeface="Arial"/>
                         </a:rPr>
-                        <a:t>195</a:t>
+                        <a:t>-160</a:t>
                       </a:r>
                     </a:p>
                   </a:txBody>
@@ -22452,7 +22452,7 @@
                           </a:solidFill>
                           <a:latin typeface="Arial"/>
                         </a:rPr>
-                        <a:t>+319</a:t>
+                        <a:t>+674</a:t>
                       </a:r>
                     </a:p>
                   </a:txBody>
@@ -22498,7 +22498,7 @@
                           </a:solidFill>
                           <a:latin typeface="Arial"/>
                         </a:rPr>
-                        <a:t>+163,1%</a:t>
+                        <a:t>+421,8%</a:t>
                       </a:r>
                     </a:p>
                   </a:txBody>
@@ -22759,7 +22759,7 @@
                           </a:solidFill>
                           <a:latin typeface="Arial"/>
                         </a:rPr>
-                        <a:t>2 270</a:t>
+                        <a:t>1 878</a:t>
                       </a:r>
                     </a:p>
                   </a:txBody>
@@ -22805,7 +22805,7 @@
                           </a:solidFill>
                           <a:latin typeface="Arial"/>
                         </a:rPr>
-                        <a:t>+240,6%</a:t>
+                        <a:t>+311,6%</a:t>
                       </a:r>
                     </a:p>
                   </a:txBody>

</xml_diff>

<commit_message>
October forecast: revenue -7/31 for app outage (summary, E-Com, deck); master unchanged
Co-Authored-By: Claude Opus 5.5 <noreply@anthropic.com>
Claude-Session: https://claude.ai/code/session_0142u1JgEJ5Z4iqbgjpLWfcB
</commit_message>
<xml_diff>
--- a/OMNI_weekly_AdTech_Sept.pptx
+++ b/OMNI_weekly_AdTech_Sept.pptx
@@ -15350,7 +15350,7 @@
           <a:p>
             <a:r>
               <a:rPr lang="ru-RU" dirty="0"/>
-              <a:t>* - Прогноз 2026 = факт 9 мес. + прогноз 3 мес.; сентябрь — предв. факт (выручка по Rev); бюджет — ревизия BU (выручка — утверждённый BU); «+» к бюджету — улучшение (по расходам — экономия)</a:t>
+              <a:t>* - Прогноз 2026 = факт 9 мес. + прогноз 3 мес.; сентябрь — предв. факт (выручка по Rev); выручка окт. снижена на 7/31 (сбой приложения); бюджет — ревизия BU (выручка — утв. BU); «+» к бюджету — улучшение (по расходам — экономия)</a:t>
             </a:r>
             <a:br>
               <a:rPr lang="ru-RU" dirty="0"/>
@@ -16749,7 +16749,7 @@
                           </a:solidFill>
                           <a:latin typeface="Arial"/>
                         </a:rPr>
-                        <a:t>5 728</a:t>
+                        <a:t>5 580</a:t>
                       </a:r>
                     </a:p>
                   </a:txBody>
@@ -16844,7 +16844,7 @@
                           </a:solidFill>
                           <a:latin typeface="Arial"/>
                         </a:rPr>
-                        <a:t>+63,0%</a:t>
+                        <a:t>+58,8%</a:t>
                       </a:r>
                     </a:p>
                   </a:txBody>
@@ -17320,7 +17320,7 @@
                           </a:solidFill>
                           <a:latin typeface="Arial"/>
                         </a:rPr>
-                        <a:t>КПЭ 2026: прогноз 1,22 млрд руб. при цели 1,0 млрд</a:t>
+                        <a:t>КПЭ 2026: прогноз 1,19 млрд руб. при цели 1,0 млрд</a:t>
                       </a:r>
                     </a:p>
                   </a:txBody>
@@ -17406,7 +17406,7 @@
                           </a:solidFill>
                           <a:latin typeface="Arial"/>
                         </a:rPr>
-                        <a:t>1 222</a:t>
+                        <a:t>1 193</a:t>
                       </a:r>
                     </a:p>
                   </a:txBody>
@@ -17501,7 +17501,7 @@
                           </a:solidFill>
                           <a:latin typeface="Arial"/>
                         </a:rPr>
-                        <a:t>+22,2%</a:t>
+                        <a:t>+19,3%</a:t>
                       </a:r>
                     </a:p>
                   </a:txBody>
@@ -18063,7 +18063,7 @@
                           </a:solidFill>
                           <a:latin typeface="Arial"/>
                         </a:rPr>
-                        <a:t>6 346</a:t>
+                        <a:t>6 175</a:t>
                       </a:r>
                     </a:p>
                   </a:txBody>
@@ -18158,7 +18158,7 @@
                           </a:solidFill>
                           <a:latin typeface="Arial"/>
                         </a:rPr>
-                        <a:t>+266,0%</a:t>
+                        <a:t>+256,1%</a:t>
                       </a:r>
                     </a:p>
                   </a:txBody>
@@ -18720,7 +18720,7 @@
                           </a:solidFill>
                           <a:latin typeface="Arial"/>
                         </a:rPr>
-                        <a:t>4 455</a:t>
+                        <a:t>4 368</a:t>
                       </a:r>
                     </a:p>
                   </a:txBody>
@@ -18815,7 +18815,7 @@
                           </a:solidFill>
                           <a:latin typeface="Arial"/>
                         </a:rPr>
-                        <a:t>+8,3%</a:t>
+                        <a:t>+6,2%</a:t>
                       </a:r>
                     </a:p>
                   </a:txBody>
@@ -19391,7 +19391,7 @@
                           </a:solidFill>
                           <a:latin typeface="Arial"/>
                         </a:rPr>
-                        <a:t>10 800</a:t>
+                        <a:t>10 543</a:t>
                       </a:r>
                     </a:p>
                   </a:txBody>
@@ -19490,7 +19490,7 @@
                           </a:solidFill>
                           <a:latin typeface="Arial"/>
                         </a:rPr>
-                        <a:t>+84,7%</a:t>
+                        <a:t>+80,3%</a:t>
                       </a:r>
                     </a:p>
                   </a:txBody>
@@ -19596,7 +19596,7 @@
                           </a:solidFill>
                           <a:latin typeface="Arial"/>
                         </a:rPr>
-                        <a:t>×6,2</a:t>
+                        <a:t>×6,0</a:t>
                       </a:r>
                     </a:p>
                   </a:txBody>
@@ -20727,7 +20727,7 @@
                           </a:solidFill>
                           <a:latin typeface="Arial"/>
                         </a:rPr>
-                        <a:t>8 436</a:t>
+                        <a:t>8 179</a:t>
                       </a:r>
                     </a:p>
                   </a:txBody>
@@ -20826,7 +20826,7 @@
                           </a:solidFill>
                           <a:latin typeface="Arial"/>
                         </a:rPr>
-                        <a:t>+175,9%</a:t>
+                        <a:t>+167,5%</a:t>
                       </a:r>
                     </a:p>
                   </a:txBody>
@@ -20932,7 +20932,7 @@
                           </a:solidFill>
                           <a:latin typeface="Arial"/>
                         </a:rPr>
-                        <a:t>×7,8</a:t>
+                        <a:t>×7,5</a:t>
                       </a:r>
                     </a:p>
                   </a:txBody>
@@ -21384,7 +21384,7 @@
                           </a:solidFill>
                           <a:latin typeface="Arial"/>
                         </a:rPr>
-                        <a:t>3 364</a:t>
+                        <a:t>3 216</a:t>
                       </a:r>
                     </a:p>
                   </a:txBody>
@@ -21479,7 +21479,7 @@
                           </a:solidFill>
                           <a:latin typeface="Arial"/>
                         </a:rPr>
-                        <a:t>+363,8%</a:t>
+                        <a:t>+343,4%</a:t>
                       </a:r>
                     </a:p>
                   </a:txBody>
@@ -22710,7 +22710,7 @@
                           </a:solidFill>
                           <a:latin typeface="Arial"/>
                         </a:rPr>
-                        <a:t>7 732</a:t>
+                        <a:t>7 475</a:t>
                       </a:r>
                     </a:p>
                   </a:txBody>
@@ -22805,7 +22805,7 @@
                           </a:solidFill>
                           <a:latin typeface="Arial"/>
                         </a:rPr>
-                        <a:t>+311,6%</a:t>
+                        <a:t>+297,9%</a:t>
                       </a:r>
                     </a:p>
                   </a:txBody>
@@ -23061,7 +23061,7 @@
           <a:p>
             <a:r>
               <a:rPr lang="ru-RU" dirty="0"/>
-              <a:t>* - Прогноз 2026 = факт 9 мес. + прогноз 3 мес. EBITDA для КПЭ — без базовой выручки E-com. Оценка: 0,5 — при мин., 1,0 — при цели, 1,5 — при макс. и выше, между точками — линейно</a:t>
+              <a:t>* - Прогноз 2026 = факт 9 мес. + прогноз 3 мес. (выручка окт. −7/31, сбой приложения). EBITDA для КПЭ — без базовой выручки E-com. Оценка: 0,5 — при мин., 1,0 — при цели, 1,5 — при макс. и выше, между точками — линейно</a:t>
             </a:r>
             <a:br>
               <a:rPr lang="ru-RU" dirty="0"/>
@@ -24096,7 +24096,7 @@
                           </a:solidFill>
                           <a:latin typeface="Arial"/>
                         </a:rPr>
-                        <a:t>4,91</a:t>
+                        <a:t>4,75</a:t>
                       </a:r>
                     </a:p>
                   </a:txBody>
@@ -24139,7 +24139,7 @@
                           </a:solidFill>
                           <a:latin typeface="Arial"/>
                         </a:rPr>
-                        <a:t>142%</a:t>
+                        <a:t>138%</a:t>
                       </a:r>
                     </a:p>
                   </a:txBody>
@@ -24587,7 +24587,7 @@
                           </a:solidFill>
                           <a:latin typeface="Arial"/>
                         </a:rPr>
-                        <a:t>4,91</a:t>
+                        <a:t>4,75</a:t>
                       </a:r>
                     </a:p>
                   </a:txBody>
@@ -24630,7 +24630,7 @@
                           </a:solidFill>
                           <a:latin typeface="Arial"/>
                         </a:rPr>
-                        <a:t>142%</a:t>
+                        <a:t>138%</a:t>
                       </a:r>
                     </a:p>
                   </a:txBody>
@@ -24720,7 +24720,7 @@
                           </a:solidFill>
                           <a:latin typeface="Arial"/>
                         </a:rPr>
-                        <a:t>Без учёта базовой выручки E-com (3,52 млрд руб.)</a:t>
+                        <a:t>Без учёта базовой выручки E-com (3,43 млрд руб.)</a:t>
                       </a:r>
                     </a:p>
                   </a:txBody>
@@ -25081,7 +25081,7 @@
                           </a:solidFill>
                           <a:latin typeface="Arial"/>
                         </a:rPr>
-                        <a:t>1,22</a:t>
+                        <a:t>1,19</a:t>
                       </a:r>
                     </a:p>
                   </a:txBody>
@@ -25124,7 +25124,7 @@
                           </a:solidFill>
                           <a:latin typeface="Arial"/>
                         </a:rPr>
-                        <a:t>122%</a:t>
+                        <a:t>119%</a:t>
                       </a:r>
                     </a:p>
                   </a:txBody>
@@ -25169,7 +25169,7 @@
                           </a:solidFill>
                           <a:latin typeface="Arial"/>
                         </a:rPr>
-                        <a:t>1,5</a:t>
+                        <a:t>1,48</a:t>
                       </a:r>
                     </a:p>
                   </a:txBody>

</xml_diff>